<commit_message>
loss weight increase to 5
</commit_message>
<xml_diff>
--- a/meeting_updates/Ovarain_cancer.pptx
+++ b/meeting_updates/Ovarain_cancer.pptx
@@ -5,7 +5,7 @@
     <p:sldMasterId id="2147483648" r:id="rId1"/>
   </p:sldMasterIdLst>
   <p:notesMasterIdLst>
-    <p:notesMasterId r:id="rId8"/>
+    <p:notesMasterId r:id="rId10"/>
   </p:notesMasterIdLst>
   <p:sldIdLst>
     <p:sldId id="311" r:id="rId2"/>
@@ -14,6 +14,8 @@
     <p:sldId id="307" r:id="rId5"/>
     <p:sldId id="312" r:id="rId6"/>
     <p:sldId id="313" r:id="rId7"/>
+    <p:sldId id="315" r:id="rId8"/>
+    <p:sldId id="314" r:id="rId9"/>
   </p:sldIdLst>
   <p:sldSz cx="12192000" cy="6858000"/>
   <p:notesSz cx="6858000" cy="9144000"/>
@@ -202,7 +204,7 @@
           <a:p>
             <a:fld id="{F3EF865D-16BF-F547-895B-EE3A5AC7B88E}" type="datetimeFigureOut">
               <a:rPr lang="en-US" smtClean="0"/>
-              <a:t>7/28/2025</a:t>
+              <a:t>8/4/2025</a:t>
             </a:fld>
             <a:endParaRPr lang="en-US"/>
           </a:p>
@@ -11715,6 +11717,213 @@
     <p:extLst>
       <p:ext uri="{BB962C8B-B14F-4D97-AF65-F5344CB8AC3E}">
         <p14:creationId xmlns:p14="http://schemas.microsoft.com/office/powerpoint/2010/main" val="3377762699"/>
+      </p:ext>
+    </p:extLst>
+  </p:cSld>
+  <p:clrMapOvr>
+    <a:masterClrMapping/>
+  </p:clrMapOvr>
+</p:sld>
+</file>
+
+<file path=ppt/slides/slide7.xml><?xml version="1.0" encoding="utf-8"?>
+<p:sld xmlns:a="http://schemas.openxmlformats.org/drawingml/2006/main" xmlns:r="http://schemas.openxmlformats.org/officeDocument/2006/relationships" xmlns:p="http://schemas.openxmlformats.org/presentationml/2006/main">
+  <p:cSld>
+    <p:spTree>
+      <p:nvGrpSpPr>
+        <p:cNvPr id="1" name=""/>
+        <p:cNvGrpSpPr/>
+        <p:nvPr/>
+      </p:nvGrpSpPr>
+      <p:grpSpPr>
+        <a:xfrm>
+          <a:off x="0" y="0"/>
+          <a:ext cx="0" cy="0"/>
+          <a:chOff x="0" y="0"/>
+          <a:chExt cx="0" cy="0"/>
+        </a:xfrm>
+      </p:grpSpPr>
+      <p:sp>
+        <p:nvSpPr>
+          <p:cNvPr id="2" name="Content Placeholder 1">
+            <a:extLst>
+              <a:ext uri="{FF2B5EF4-FFF2-40B4-BE49-F238E27FC236}">
+                <a16:creationId xmlns:a16="http://schemas.microsoft.com/office/drawing/2014/main" id="{7C77BD06-FD16-53D2-270F-091690D198A9}"/>
+              </a:ext>
+            </a:extLst>
+          </p:cNvPr>
+          <p:cNvSpPr>
+            <a:spLocks noGrp="1"/>
+          </p:cNvSpPr>
+          <p:nvPr>
+            <p:ph sz="quarter" idx="13"/>
+          </p:nvPr>
+        </p:nvSpPr>
+        <p:spPr/>
+        <p:txBody>
+          <a:bodyPr/>
+          <a:lstStyle/>
+          <a:p>
+            <a:endParaRPr lang="en-US"/>
+          </a:p>
+        </p:txBody>
+      </p:sp>
+    </p:spTree>
+    <p:extLst>
+      <p:ext uri="{BB962C8B-B14F-4D97-AF65-F5344CB8AC3E}">
+        <p14:creationId xmlns:p14="http://schemas.microsoft.com/office/powerpoint/2010/main" val="3452228504"/>
+      </p:ext>
+    </p:extLst>
+  </p:cSld>
+  <p:clrMapOvr>
+    <a:masterClrMapping/>
+  </p:clrMapOvr>
+</p:sld>
+</file>
+
+<file path=ppt/slides/slide8.xml><?xml version="1.0" encoding="utf-8"?>
+<p:sld xmlns:a="http://schemas.openxmlformats.org/drawingml/2006/main" xmlns:r="http://schemas.openxmlformats.org/officeDocument/2006/relationships" xmlns:p="http://schemas.openxmlformats.org/presentationml/2006/main">
+  <p:cSld>
+    <p:spTree>
+      <p:nvGrpSpPr>
+        <p:cNvPr id="1" name="">
+          <a:extLst>
+            <a:ext uri="{FF2B5EF4-FFF2-40B4-BE49-F238E27FC236}">
+              <a16:creationId xmlns:a16="http://schemas.microsoft.com/office/drawing/2014/main" id="{BABFEF7B-EFE8-BFE9-2A2D-147DEACF786A}"/>
+            </a:ext>
+          </a:extLst>
+        </p:cNvPr>
+        <p:cNvGrpSpPr/>
+        <p:nvPr/>
+      </p:nvGrpSpPr>
+      <p:grpSpPr>
+        <a:xfrm>
+          <a:off x="0" y="0"/>
+          <a:ext cx="0" cy="0"/>
+          <a:chOff x="0" y="0"/>
+          <a:chExt cx="0" cy="0"/>
+        </a:xfrm>
+      </p:grpSpPr>
+      <p:sp>
+        <p:nvSpPr>
+          <p:cNvPr id="2" name="Title 1">
+            <a:extLst>
+              <a:ext uri="{FF2B5EF4-FFF2-40B4-BE49-F238E27FC236}">
+                <a16:creationId xmlns:a16="http://schemas.microsoft.com/office/drawing/2014/main" id="{B7605A9B-E959-BC88-C138-919D892DFD7D}"/>
+              </a:ext>
+            </a:extLst>
+          </p:cNvPr>
+          <p:cNvSpPr>
+            <a:spLocks noGrp="1"/>
+          </p:cNvSpPr>
+          <p:nvPr>
+            <p:ph type="title"/>
+          </p:nvPr>
+        </p:nvSpPr>
+        <p:spPr>
+          <a:xfrm>
+            <a:off x="838200" y="365125"/>
+            <a:ext cx="10515600" cy="1325563"/>
+          </a:xfrm>
+        </p:spPr>
+        <p:txBody>
+          <a:bodyPr anchor="ctr">
+            <a:normAutofit/>
+          </a:bodyPr>
+          <a:lstStyle/>
+          <a:p>
+            <a:r>
+              <a:rPr lang="en-US" dirty="0"/>
+              <a:t>Experimental Results</a:t>
+            </a:r>
+          </a:p>
+        </p:txBody>
+      </p:sp>
+      <p:pic>
+        <p:nvPicPr>
+          <p:cNvPr id="5" name="Content Placeholder 4" descr="A graph showing a number of seeds&#10;&#10;AI-generated content may be incorrect.">
+            <a:extLst>
+              <a:ext uri="{FF2B5EF4-FFF2-40B4-BE49-F238E27FC236}">
+                <a16:creationId xmlns:a16="http://schemas.microsoft.com/office/drawing/2014/main" id="{34F7142C-B456-370F-4373-35D12300F940}"/>
+              </a:ext>
+            </a:extLst>
+          </p:cNvPr>
+          <p:cNvPicPr>
+            <a:picLocks noGrp="1" noChangeAspect="1"/>
+          </p:cNvPicPr>
+          <p:nvPr>
+            <p:ph idx="1"/>
+          </p:nvPr>
+        </p:nvPicPr>
+        <p:blipFill>
+          <a:blip r:embed="rId2"/>
+          <a:stretch>
+            <a:fillRect/>
+          </a:stretch>
+        </p:blipFill>
+        <p:spPr>
+          <a:xfrm>
+            <a:off x="4659087" y="1490664"/>
+            <a:ext cx="6694713" cy="4686300"/>
+          </a:xfrm>
+        </p:spPr>
+      </p:pic>
+      <p:sp>
+        <p:nvSpPr>
+          <p:cNvPr id="8" name="TextBox 7">
+            <a:extLst>
+              <a:ext uri="{FF2B5EF4-FFF2-40B4-BE49-F238E27FC236}">
+                <a16:creationId xmlns:a16="http://schemas.microsoft.com/office/drawing/2014/main" id="{A5F1ACA0-B79E-F27D-3044-B1C2D5B4AEDB}"/>
+              </a:ext>
+            </a:extLst>
+          </p:cNvPr>
+          <p:cNvSpPr txBox="1"/>
+          <p:nvPr/>
+        </p:nvSpPr>
+        <p:spPr>
+          <a:xfrm>
+            <a:off x="1007390" y="1813302"/>
+            <a:ext cx="2510725" cy="923330"/>
+          </a:xfrm>
+          <a:prstGeom prst="rect">
+            <a:avLst/>
+          </a:prstGeom>
+          <a:noFill/>
+        </p:spPr>
+        <p:txBody>
+          <a:bodyPr wrap="square" rtlCol="0">
+            <a:spAutoFit/>
+          </a:bodyPr>
+          <a:lstStyle/>
+          <a:p>
+            <a:r>
+              <a:rPr lang="en-US" dirty="0"/>
+              <a:t>PA Image Features: </a:t>
+            </a:r>
+          </a:p>
+          <a:p>
+            <a:r>
+              <a:rPr lang="en-US" dirty="0"/>
+              <a:t> 1) SO2 </a:t>
+            </a:r>
+          </a:p>
+          <a:p>
+            <a:r>
+              <a:rPr lang="en-US" dirty="0"/>
+              <a:t>2) </a:t>
+            </a:r>
+            <a:r>
+              <a:rPr lang="en-US" dirty="0" err="1"/>
+              <a:t>THb</a:t>
+            </a:r>
+            <a:endParaRPr lang="en-US" dirty="0"/>
+          </a:p>
+        </p:txBody>
+      </p:sp>
+    </p:spTree>
+    <p:extLst>
+      <p:ext uri="{BB962C8B-B14F-4D97-AF65-F5344CB8AC3E}">
+        <p14:creationId xmlns:p14="http://schemas.microsoft.com/office/powerpoint/2010/main" val="3951455384"/>
       </p:ext>
     </p:extLst>
   </p:cSld>

</xml_diff>